<commit_message>
Move demo deck generator into the repo
- design/tools/deliverables/deck: build script with relative paths, vendored
  apply_theme helper and the style-sheet crop it uses
- npm run deck in design/tools; pptxgenjs as a local devDependency
- Deck now uses the live board-ours.png export instead of a stale copy

Co-Authored-By: Claude Opus 5.5 <noreply@anthropic.com>
</commit_message>
<xml_diff>
--- a/deliverables/demo-deck.pptx
+++ b/deliverables/demo-deck.pptx
@@ -1861,7 +1861,7 @@
       </p:sp>
       <p:pic>
         <p:nvPicPr>
-          <p:cNvPr id="7" name="Image 0" descr="C:/Users/aksuc/Desktop/proje_odev/design/export/screens/01-promise-light.png">    </p:cNvPr>
+          <p:cNvPr id="7" name="Image 0" descr="C:\Users\aksuc\Desktop\proje_odev\design\export/screens/01-promise-light.png">    </p:cNvPr>
           <p:cNvPicPr>
             <a:picLocks noChangeAspect="1"/>
           </p:cNvPicPr>
@@ -1912,7 +1912,7 @@
       </p:sp>
       <p:pic>
         <p:nvPicPr>
-          <p:cNvPr id="9" name="Image 1" descr="C:/Users/aksuc/Desktop/proje_odev/design/export/screens/07-reveal-light.png">    </p:cNvPr>
+          <p:cNvPr id="9" name="Image 1" descr="C:\Users\aksuc\Desktop\proje_odev\design\export/screens/07-reveal-light.png">    </p:cNvPr>
           <p:cNvPicPr>
             <a:picLocks noChangeAspect="1"/>
           </p:cNvPicPr>
@@ -2206,7 +2206,7 @@
       </p:sp>
       <p:pic>
         <p:nvPicPr>
-          <p:cNvPr id="6" name="Image 0" descr="C:/Users/aksuc/Desktop/proje_odev/design/export/screens/13-home-light.png">    </p:cNvPr>
+          <p:cNvPr id="6" name="Image 0" descr="C:\Users\aksuc\Desktop\proje_odev\design\export/screens/13-home-light.png">    </p:cNvPr>
           <p:cNvPicPr>
             <a:picLocks noChangeAspect="1"/>
           </p:cNvPicPr>
@@ -2257,7 +2257,7 @@
       </p:sp>
       <p:pic>
         <p:nvPicPr>
-          <p:cNvPr id="8" name="Image 1" descr="C:/Users/aksuc/Desktop/proje_odev/design/export/screens/11-paywall-light.png">    </p:cNvPr>
+          <p:cNvPr id="8" name="Image 1" descr="C:\Users\aksuc\Desktop\proje_odev\design\export/screens/11-paywall-light.png">    </p:cNvPr>
           <p:cNvPicPr>
             <a:picLocks noChangeAspect="1"/>
           </p:cNvPicPr>
@@ -3508,7 +3508,7 @@
       </p:sp>
       <p:pic>
         <p:nvPicPr>
-          <p:cNvPr id="15" name="Image 0" descr="C:/Users/aksuc/Desktop/proje_odev/design/export/screens/01-promise-light.png">    </p:cNvPr>
+          <p:cNvPr id="15" name="Image 0" descr="C:\Users\aksuc\Desktop\proje_odev\design\export/screens/01-promise-light.png">    </p:cNvPr>
           <p:cNvPicPr>
             <a:picLocks noChangeAspect="1"/>
           </p:cNvPicPr>
@@ -4101,7 +4101,7 @@
       </p:sp>
       <p:pic>
         <p:nvPicPr>
-          <p:cNvPr id="17" name="Image 0" descr="C:/Users/aksuc/AppData/Local/Temp/claude/C--Users-aksuc-Desktop-proje-odev/778ab7f7-ea63-40ac-9532-5fd9330f50b7/scratchpad/img/style_crop.png">    </p:cNvPr>
+          <p:cNvPr id="17" name="Image 0" descr="C:\Users\aksuc\Desktop\proje_odev\design\tools\deliverables\deck\img/style_crop.png">    </p:cNvPr>
           <p:cNvPicPr>
             <a:picLocks noChangeAspect="1"/>
           </p:cNvPicPr>
@@ -4195,7 +4195,7 @@
       </p:sp>
       <p:pic>
         <p:nvPicPr>
-          <p:cNvPr id="3" name="Image 0" descr="C:/Users/aksuc/AppData/Local/Temp/claude/C--Users-aksuc-Desktop-proje-odev/778ab7f7-ea63-40ac-9532-5fd9330f50b7/scratchpad/img/board.png">    </p:cNvPr>
+          <p:cNvPr id="3" name="Image 0" descr="C:\Users\aksuc\Desktop\proje_odev\design\export/board-ours.png">    </p:cNvPr>
           <p:cNvPicPr>
             <a:picLocks noChangeAspect="1"/>
           </p:cNvPicPr>
@@ -6087,7 +6087,7 @@
       </p:sp>
       <p:pic>
         <p:nvPicPr>
-          <p:cNvPr id="16" name="Image 0" descr="C:/Users/aksuc/Desktop/proje_odev/design/export/screens/05-parents-light.png">    </p:cNvPr>
+          <p:cNvPr id="16" name="Image 0" descr="C:\Users\aksuc\Desktop\proje_odev\design\export/screens/05-parents-light.png">    </p:cNvPr>
           <p:cNvPicPr>
             <a:picLocks noChangeAspect="1"/>
           </p:cNvPicPr>
@@ -6177,7 +6177,7 @@
       </p:sp>
       <p:pic>
         <p:nvPicPr>
-          <p:cNvPr id="19" name="Image 1" descr="C:/Users/aksuc/Desktop/proje_odev/design/export/screens/07-reveal-light.png">    </p:cNvPr>
+          <p:cNvPr id="19" name="Image 1" descr="C:\Users\aksuc\Desktop\proje_odev\design\export/screens/07-reveal-light.png">    </p:cNvPr>
           <p:cNvPicPr>
             <a:picLocks noChangeAspect="1"/>
           </p:cNvPicPr>
@@ -6267,7 +6267,7 @@
       </p:sp>
       <p:pic>
         <p:nvPicPr>
-          <p:cNvPr id="22" name="Image 2" descr="C:/Users/aksuc/Desktop/proje_odev/design/export/screens/09-plan-light.png">    </p:cNvPr>
+          <p:cNvPr id="22" name="Image 2" descr="C:\Users\aksuc\Desktop\proje_odev\design\export/screens/09-plan-light.png">    </p:cNvPr>
           <p:cNvPicPr>
             <a:picLocks noChangeAspect="1"/>
           </p:cNvPicPr>
@@ -6467,7 +6467,7 @@
       </p:sp>
       <p:pic>
         <p:nvPicPr>
-          <p:cNvPr id="4" name="Image 0" descr="C:/Users/aksuc/Desktop/proje_odev/design/export/screens/11-paywall-light.png">    </p:cNvPr>
+          <p:cNvPr id="4" name="Image 0" descr="C:\Users\aksuc\Desktop\proje_odev\design\export/screens/11-paywall-light.png">    </p:cNvPr>
           <p:cNvPicPr>
             <a:picLocks noChangeAspect="1"/>
           </p:cNvPicPr>

</xml_diff>

<commit_message>
Add GoTall teardown from public onboarding screens
- research/competitor-screens: 44 onboarding stills + paywall from
  ScreensDesign's public page (watermarked, older build), with SOURCE.md
- teardown-data.json: per-screen annotations, friction points, counts
  from the stills; teardown PDF now shows all 44 screens on 6 pages
- Correct the paywall urgency claim everywhere: a "Special offer"
  countdown reading 2:59:59, not a 3-minute timer
- Deck evidence slide: 33 screens to GoTall's paywall vs result on our
  screen 7; value-prop PDF regenerated
- .gitignore for regenerable review sheets, caches and store images

Co-Authored-By: Claude Opus 5.5 <noreply@anthropic.com>
</commit_message>
<xml_diff>
--- a/deliverables/demo-deck.pptx
+++ b/deliverables/demo-deck.pptx
@@ -1303,7 +1303,7 @@
           <a:p>
             <a:r>
               <a:rPr lang="en-US" dirty="0"/>
-              <a:t>Here is the side-by-side. Questions to result: 31 for GoTall against 4 for us, and our result is shown before the paywall, theirs is not. Seconds, taps and the clarity score are our own measurements from testing both apps with classmates: read the numbers out from the table. Our internal QA audit also found no dead ends in the flow.</a:t>
+              <a:t>Here is the side-by-side. GoTall shows 33 screens before its paywall and the result is still locked; we show the result on screen 7 after 4 questions, free. Screen and tap counts for GoTall come from ScreensDesign's public recording of its onboarding. Seconds, taps and the clarity score are our own measurements from testing both apps with classmates: read the numbers out from the table. Our internal QA audit also found no dead ends in the flow.</a:t>
             </a:r>
             <a:endParaRPr lang="en-US" dirty="0"/>
           </a:p>
@@ -2461,7 +2461,7 @@
                 <a:ea typeface="Arial" pitchFamily="34" charset="-122"/>
                 <a:cs typeface="Arial" pitchFamily="34" charset="-120"/>
               </a:rPr>
-              <a:t>A height predictor app. 31-step quiz, then a paywall, then the result.</a:t>
+              <a:t>A height predictor app. 33 screens of questions and claims, then a paywall. The result stays locked.</a:t>
             </a:r>
             <a:endParaRPr lang="en-US" sz="1600" dirty="0"/>
           </a:p>
@@ -7196,7 +7196,7 @@
                 <a:ea typeface="Arial" pitchFamily="34" charset="-122"/>
                 <a:cs typeface="Arial" pitchFamily="34" charset="-120"/>
               </a:rPr>
-              <a:t>3-minute countdown timer</a:t>
+              <a:t>"Special offer" countdown (2:59:59)</a:t>
             </a:r>
             <a:endParaRPr lang="en-US" sz="1600" dirty="0"/>
           </a:p>
@@ -7342,7 +7342,7 @@
                 <a:gridCol w="2011680"/>
                 <a:gridCol w="2194560"/>
               </a:tblGrid>
-              <a:tr h="685800">
+              <a:tr h="621792">
                 <a:tc>
                   <a:txBody>
                     <a:bodyPr/>
@@ -7548,7 +7548,7 @@
                   </a:tcPr>
                 </a:tc>
               </a:tr>
-              <a:tr h="685800">
+              <a:tr h="621792">
                 <a:tc>
                   <a:txBody>
                     <a:bodyPr/>
@@ -7566,7 +7566,7 @@
                           <a:ea typeface="Arial" pitchFamily="34" charset="-122"/>
                           <a:cs typeface="Arial" pitchFamily="34" charset="-120"/>
                         </a:rPr>
-                        <a:t>Questions to result</a:t>
+                        <a:t>Screens before the paywall</a:t>
                       </a:r>
                       <a:endParaRPr lang="en-US" sz="2000" dirty="0">
                         <a:latin typeface="Arial" charset="0"/>
@@ -7634,7 +7634,213 @@
                           <a:ea typeface="Arial" pitchFamily="34" charset="-122"/>
                           <a:cs typeface="Arial" pitchFamily="34" charset="-120"/>
                         </a:rPr>
-                        <a:t>31</a:t>
+                        <a:t>33</a:t>
+                      </a:r>
+                      <a:endParaRPr lang="en-US" sz="2000" dirty="0">
+                        <a:latin typeface="Arial" charset="0"/>
+                        <a:ea typeface="Arial" charset="0"/>
+                        <a:cs typeface="Arial" charset="0"/>
+                      </a:endParaRPr>
+                    </a:p>
+                  </a:txBody>
+                  <a:tcPr marL="137160" marR="137160" marT="0" marB="0" anchor="ctr">
+                    <a:lnL w="12700" cap="flat" cmpd="sng" algn="ctr">
+                      <a:solidFill>
+                        <a:srgbClr val="E3E0D8"/>
+                      </a:solidFill>
+                      <a:prstDash val="solid"/>
+                      <a:round/>
+                      <a:headEnd type="none" w="med" len="med"/>
+                      <a:tailEnd type="none" w="med" len="med"/>
+                    </a:lnL>
+                    <a:lnR w="12700" cap="flat" cmpd="sng" algn="ctr">
+                      <a:solidFill>
+                        <a:srgbClr val="E3E0D8"/>
+                      </a:solidFill>
+                      <a:prstDash val="solid"/>
+                      <a:round/>
+                      <a:headEnd type="none" w="med" len="med"/>
+                      <a:tailEnd type="none" w="med" len="med"/>
+                    </a:lnR>
+                    <a:lnT w="12700" cap="flat" cmpd="sng" algn="ctr">
+                      <a:solidFill>
+                        <a:srgbClr val="E3E0D8"/>
+                      </a:solidFill>
+                      <a:prstDash val="solid"/>
+                      <a:round/>
+                      <a:headEnd type="none" w="med" len="med"/>
+                      <a:tailEnd type="none" w="med" len="med"/>
+                    </a:lnT>
+                    <a:lnB w="12700" cap="flat" cmpd="sng" algn="ctr">
+                      <a:solidFill>
+                        <a:srgbClr val="E3E0D8"/>
+                      </a:solidFill>
+                      <a:prstDash val="solid"/>
+                      <a:round/>
+                      <a:headEnd type="none" w="med" len="med"/>
+                      <a:tailEnd type="none" w="med" len="med"/>
+                    </a:lnB>
+                    <a:solidFill>
+                      <a:srgbClr val="FFFFFF"/>
+                    </a:solidFill>
+                  </a:tcPr>
+                </a:tc>
+                <a:tc>
+                  <a:txBody>
+                    <a:bodyPr/>
+                    <a:lstStyle/>
+                    <a:p>
+                      <a:pPr indent="0" marL="0">
+                        <a:buNone/>
+                      </a:pPr>
+                      <a:r>
+                        <a:rPr lang="en-US" sz="2000" b="1" dirty="0">
+                          <a:solidFill>
+                            <a:srgbClr val="141414"/>
+                          </a:solidFill>
+                          <a:latin typeface="Arial" pitchFamily="34" charset="0"/>
+                          <a:ea typeface="Arial" pitchFamily="34" charset="-122"/>
+                          <a:cs typeface="Arial" pitchFamily="34" charset="-120"/>
+                        </a:rPr>
+                        <a:t>11</a:t>
+                      </a:r>
+                      <a:endParaRPr lang="en-US" sz="2000" dirty="0">
+                        <a:latin typeface="Arial" charset="0"/>
+                        <a:ea typeface="Arial" charset="0"/>
+                        <a:cs typeface="Arial" charset="0"/>
+                      </a:endParaRPr>
+                    </a:p>
+                  </a:txBody>
+                  <a:tcPr marL="137160" marR="137160" marT="0" marB="0" anchor="ctr">
+                    <a:lnL w="12700" cap="flat" cmpd="sng" algn="ctr">
+                      <a:solidFill>
+                        <a:srgbClr val="E3E0D8"/>
+                      </a:solidFill>
+                      <a:prstDash val="solid"/>
+                      <a:round/>
+                      <a:headEnd type="none" w="med" len="med"/>
+                      <a:tailEnd type="none" w="med" len="med"/>
+                    </a:lnL>
+                    <a:lnR w="12700" cap="flat" cmpd="sng" algn="ctr">
+                      <a:solidFill>
+                        <a:srgbClr val="E3E0D8"/>
+                      </a:solidFill>
+                      <a:prstDash val="solid"/>
+                      <a:round/>
+                      <a:headEnd type="none" w="med" len="med"/>
+                      <a:tailEnd type="none" w="med" len="med"/>
+                    </a:lnR>
+                    <a:lnT w="12700" cap="flat" cmpd="sng" algn="ctr">
+                      <a:solidFill>
+                        <a:srgbClr val="E3E0D8"/>
+                      </a:solidFill>
+                      <a:prstDash val="solid"/>
+                      <a:round/>
+                      <a:headEnd type="none" w="med" len="med"/>
+                      <a:tailEnd type="none" w="med" len="med"/>
+                    </a:lnT>
+                    <a:lnB w="12700" cap="flat" cmpd="sng" algn="ctr">
+                      <a:solidFill>
+                        <a:srgbClr val="E3E0D8"/>
+                      </a:solidFill>
+                      <a:prstDash val="solid"/>
+                      <a:round/>
+                      <a:headEnd type="none" w="med" len="med"/>
+                      <a:tailEnd type="none" w="med" len="med"/>
+                    </a:lnB>
+                    <a:solidFill>
+                      <a:srgbClr val="EAF8C2"/>
+                    </a:solidFill>
+                  </a:tcPr>
+                </a:tc>
+              </a:tr>
+              <a:tr h="621792">
+                <a:tc>
+                  <a:txBody>
+                    <a:bodyPr/>
+                    <a:lstStyle/>
+                    <a:p>
+                      <a:pPr indent="0" marL="0">
+                        <a:buNone/>
+                      </a:pPr>
+                      <a:r>
+                        <a:rPr lang="en-US" sz="2000" dirty="0">
+                          <a:solidFill>
+                            <a:srgbClr val="141414"/>
+                          </a:solidFill>
+                          <a:latin typeface="Arial" pitchFamily="34" charset="0"/>
+                          <a:ea typeface="Arial" pitchFamily="34" charset="-122"/>
+                          <a:cs typeface="Arial" pitchFamily="34" charset="-120"/>
+                        </a:rPr>
+                        <a:t>Questions before the result</a:t>
+                      </a:r>
+                      <a:endParaRPr lang="en-US" sz="2000" dirty="0">
+                        <a:latin typeface="Arial" charset="0"/>
+                        <a:ea typeface="Arial" charset="0"/>
+                        <a:cs typeface="Arial" charset="0"/>
+                      </a:endParaRPr>
+                    </a:p>
+                  </a:txBody>
+                  <a:tcPr marL="137160" marR="137160" marT="0" marB="0" anchor="ctr">
+                    <a:lnL w="12700" cap="flat" cmpd="sng" algn="ctr">
+                      <a:solidFill>
+                        <a:srgbClr val="E3E0D8"/>
+                      </a:solidFill>
+                      <a:prstDash val="solid"/>
+                      <a:round/>
+                      <a:headEnd type="none" w="med" len="med"/>
+                      <a:tailEnd type="none" w="med" len="med"/>
+                    </a:lnL>
+                    <a:lnR w="12700" cap="flat" cmpd="sng" algn="ctr">
+                      <a:solidFill>
+                        <a:srgbClr val="E3E0D8"/>
+                      </a:solidFill>
+                      <a:prstDash val="solid"/>
+                      <a:round/>
+                      <a:headEnd type="none" w="med" len="med"/>
+                      <a:tailEnd type="none" w="med" len="med"/>
+                    </a:lnR>
+                    <a:lnT w="12700" cap="flat" cmpd="sng" algn="ctr">
+                      <a:solidFill>
+                        <a:srgbClr val="E3E0D8"/>
+                      </a:solidFill>
+                      <a:prstDash val="solid"/>
+                      <a:round/>
+                      <a:headEnd type="none" w="med" len="med"/>
+                      <a:tailEnd type="none" w="med" len="med"/>
+                    </a:lnT>
+                    <a:lnB w="12700" cap="flat" cmpd="sng" algn="ctr">
+                      <a:solidFill>
+                        <a:srgbClr val="E3E0D8"/>
+                      </a:solidFill>
+                      <a:prstDash val="solid"/>
+                      <a:round/>
+                      <a:headEnd type="none" w="med" len="med"/>
+                      <a:tailEnd type="none" w="med" len="med"/>
+                    </a:lnB>
+                    <a:solidFill>
+                      <a:srgbClr val="FFFFFF"/>
+                    </a:solidFill>
+                  </a:tcPr>
+                </a:tc>
+                <a:tc>
+                  <a:txBody>
+                    <a:bodyPr/>
+                    <a:lstStyle/>
+                    <a:p>
+                      <a:pPr indent="0" marL="0">
+                        <a:buNone/>
+                      </a:pPr>
+                      <a:r>
+                        <a:rPr lang="en-US" sz="2000" b="1" dirty="0">
+                          <a:solidFill>
+                            <a:srgbClr val="141414"/>
+                          </a:solidFill>
+                          <a:latin typeface="Arial" pitchFamily="34" charset="0"/>
+                          <a:ea typeface="Arial" pitchFamily="34" charset="-122"/>
+                          <a:cs typeface="Arial" pitchFamily="34" charset="-120"/>
+                        </a:rPr>
+                        <a:t>25+ (then locked)</a:t>
                       </a:r>
                       <a:endParaRPr lang="en-US" sz="2000" dirty="0">
                         <a:latin typeface="Arial" charset="0"/>
@@ -7754,7 +7960,7 @@
                   </a:tcPr>
                 </a:tc>
               </a:tr>
-              <a:tr h="685800">
+              <a:tr h="621792">
                 <a:tc>
                   <a:txBody>
                     <a:bodyPr/>
@@ -7960,7 +8166,7 @@
                   </a:tcPr>
                 </a:tc>
               </a:tr>
-              <a:tr h="685800">
+              <a:tr h="621792">
                 <a:tc>
                   <a:txBody>
                     <a:bodyPr/>
@@ -8040,13 +8246,13 @@
                       <a:r>
                         <a:rPr lang="en-US" sz="2000" b="1" dirty="0">
                           <a:solidFill>
-                            <a:srgbClr val="FF5A1F"/>
+                            <a:srgbClr val="141414"/>
                           </a:solidFill>
                           <a:latin typeface="Arial" pitchFamily="34" charset="0"/>
                           <a:ea typeface="Arial" pitchFamily="34" charset="-122"/>
                           <a:cs typeface="Arial" pitchFamily="34" charset="-120"/>
                         </a:rPr>
-                        <a:t>[measure]</a:t>
+                        <a:t>n/a (locked)</a:t>
                       </a:r>
                       <a:endParaRPr lang="en-US" sz="2000" dirty="0">
                         <a:latin typeface="Arial" charset="0"/>
@@ -8108,13 +8314,13 @@
                       <a:r>
                         <a:rPr lang="en-US" sz="2000" b="1" dirty="0">
                           <a:solidFill>
-                            <a:srgbClr val="FF5A1F"/>
+                            <a:srgbClr val="141414"/>
                           </a:solidFill>
                           <a:latin typeface="Arial" pitchFamily="34" charset="0"/>
                           <a:ea typeface="Arial" pitchFamily="34" charset="-122"/>
                           <a:cs typeface="Arial" pitchFamily="34" charset="-120"/>
                         </a:rPr>
-                        <a:t>[measure]</a:t>
+                        <a:t>7</a:t>
                       </a:r>
                       <a:endParaRPr lang="en-US" sz="2000" dirty="0">
                         <a:latin typeface="Arial" charset="0"/>
@@ -8166,7 +8372,7 @@
                   </a:tcPr>
                 </a:tc>
               </a:tr>
-              <a:tr h="685800">
+              <a:tr h="621792">
                 <a:tc>
                   <a:txBody>
                     <a:bodyPr/>
@@ -8372,7 +8578,7 @@
                   </a:tcPr>
                 </a:tc>
               </a:tr>
-              <a:tr h="685800">
+              <a:tr h="621792">
                 <a:tc>
                   <a:txBody>
                     <a:bodyPr/>
@@ -8590,7 +8796,7 @@
         </p:nvSpPr>
         <p:spPr>
           <a:xfrm>
-            <a:off x="548640" y="5623560"/>
+            <a:off x="548640" y="5897880"/>
             <a:ext cx="7589520" cy="320040"/>
           </a:xfrm>
           <a:prstGeom prst="rect">
@@ -8654,7 +8860,7 @@
                 <a:ea typeface="Arial" pitchFamily="34" charset="-122"/>
                 <a:cs typeface="Arial" pitchFamily="34" charset="-120"/>
               </a:rPr>
-              <a:t>31 &gt; 4</a:t>
+              <a:t>33 vs 7</a:t>
             </a:r>
             <a:endParaRPr lang="en-US" sz="7200" dirty="0"/>
           </a:p>
@@ -8693,7 +8899,7 @@
                 <a:ea typeface="Arial" pitchFamily="34" charset="-122"/>
                 <a:cs typeface="Arial" pitchFamily="34" charset="-120"/>
               </a:rPr>
-              <a:t>questions before you see your result</a:t>
+              <a:t>screens before you see a result (GoTall: still locked)</a:t>
             </a:r>
             <a:endParaRPr lang="en-US" sz="1800" dirty="0"/>
           </a:p>

</xml_diff>

<commit_message>
Add labelled time estimates, self-assessment and change notes
- Deck and teardown: seconds marked as estimates from screen count
  (~4.5 s per screen) until stopwatch times replace them; clarity test
  left open for real classmate results
- research/self-assessment.md: rubric self-assessment (~80/100) with
  gaps and the quickest fixes
- research/design-changes.md: brief step 7 notes from the internal
  review, with a section for real user-test notes

Co-Authored-By: Claude Opus 5.5 <noreply@anthropic.com>
</commit_message>
<xml_diff>
--- a/deliverables/demo-deck.pptx
+++ b/deliverables/demo-deck.pptx
@@ -1303,7 +1303,7 @@
           <a:p>
             <a:r>
               <a:rPr lang="en-US" dirty="0"/>
-              <a:t>Here is the side-by-side. GoTall shows 33 screens before its paywall and the result is still locked; we show the result on screen 7 after 4 questions, free. Screen and tap counts for GoTall come from ScreensDesign's public recording of its onboarding. Seconds, taps and the clarity score are our own measurements from testing both apps with classmates: read the numbers out from the table. Our internal QA audit also found no dead ends in the flow.</a:t>
+              <a:t>Here is the side-by-side. GoTall shows 33 screens before its paywall and the result is still locked; we show the result on screen 7 after 4 questions, free. Screen and tap counts for GoTall come from ScreensDesign's public recording of its onboarding. The seconds marked est. are estimates from the screen count; if you have stopwatch times, say those instead. The clarity score comes from showing only the first screen of each app to five classmates. Our internal QA audit also found no dead ends in the flow.</a:t>
             </a:r>
             <a:endParaRPr lang="en-US" dirty="0"/>
           </a:p>
@@ -7342,7 +7342,7 @@
                 <a:gridCol w="2011680"/>
                 <a:gridCol w="2194560"/>
               </a:tblGrid>
-              <a:tr h="621792">
+              <a:tr h="548640">
                 <a:tc>
                   <a:txBody>
                     <a:bodyPr/>
@@ -7548,7 +7548,7 @@
                   </a:tcPr>
                 </a:tc>
               </a:tr>
-              <a:tr h="621792">
+              <a:tr h="548640">
                 <a:tc>
                   <a:txBody>
                     <a:bodyPr/>
@@ -7754,7 +7754,7 @@
                   </a:tcPr>
                 </a:tc>
               </a:tr>
-              <a:tr h="621792">
+              <a:tr h="548640">
                 <a:tc>
                   <a:txBody>
                     <a:bodyPr/>
@@ -7960,7 +7960,7 @@
                   </a:tcPr>
                 </a:tc>
               </a:tr>
-              <a:tr h="621792">
+              <a:tr h="548640">
                 <a:tc>
                   <a:txBody>
                     <a:bodyPr/>
@@ -7978,7 +7978,7 @@
                           <a:ea typeface="Arial" pitchFamily="34" charset="-122"/>
                           <a:cs typeface="Arial" pitchFamily="34" charset="-120"/>
                         </a:rPr>
-                        <a:t>Seconds to result</a:t>
+                        <a:t>Seconds to result (est.)</a:t>
                       </a:r>
                       <a:endParaRPr lang="en-US" sz="2000" dirty="0">
                         <a:latin typeface="Arial" charset="0"/>
@@ -8040,13 +8040,13 @@
                       <a:r>
                         <a:rPr lang="en-US" sz="2000" b="1" dirty="0">
                           <a:solidFill>
-                            <a:srgbClr val="FF5A1F"/>
+                            <a:srgbClr val="141414"/>
                           </a:solidFill>
                           <a:latin typeface="Arial" pitchFamily="34" charset="0"/>
                           <a:ea typeface="Arial" pitchFamily="34" charset="-122"/>
                           <a:cs typeface="Arial" pitchFamily="34" charset="-120"/>
                         </a:rPr>
-                        <a:t>[measure]</a:t>
+                        <a:t>Locked</a:t>
                       </a:r>
                       <a:endParaRPr lang="en-US" sz="2000" dirty="0">
                         <a:latin typeface="Arial" charset="0"/>
@@ -8108,13 +8108,13 @@
                       <a:r>
                         <a:rPr lang="en-US" sz="2000" b="1" dirty="0">
                           <a:solidFill>
-                            <a:srgbClr val="FF5A1F"/>
+                            <a:srgbClr val="141414"/>
                           </a:solidFill>
                           <a:latin typeface="Arial" pitchFamily="34" charset="0"/>
                           <a:ea typeface="Arial" pitchFamily="34" charset="-122"/>
                           <a:cs typeface="Arial" pitchFamily="34" charset="-120"/>
                         </a:rPr>
-                        <a:t>[measure]</a:t>
+                        <a:t>~45</a:t>
                       </a:r>
                       <a:endParaRPr lang="en-US" sz="2000" dirty="0">
                         <a:latin typeface="Arial" charset="0"/>
@@ -8166,7 +8166,213 @@
                   </a:tcPr>
                 </a:tc>
               </a:tr>
-              <a:tr h="621792">
+              <a:tr h="548640">
+                <a:tc>
+                  <a:txBody>
+                    <a:bodyPr/>
+                    <a:lstStyle/>
+                    <a:p>
+                      <a:pPr indent="0" marL="0">
+                        <a:buNone/>
+                      </a:pPr>
+                      <a:r>
+                        <a:rPr lang="en-US" sz="2000" dirty="0">
+                          <a:solidFill>
+                            <a:srgbClr val="141414"/>
+                          </a:solidFill>
+                          <a:latin typeface="Arial" pitchFamily="34" charset="0"/>
+                          <a:ea typeface="Arial" pitchFamily="34" charset="-122"/>
+                          <a:cs typeface="Arial" pitchFamily="34" charset="-120"/>
+                        </a:rPr>
+                        <a:t>Seconds to paywall (est.)</a:t>
+                      </a:r>
+                      <a:endParaRPr lang="en-US" sz="2000" dirty="0">
+                        <a:latin typeface="Arial" charset="0"/>
+                        <a:ea typeface="Arial" charset="0"/>
+                        <a:cs typeface="Arial" charset="0"/>
+                      </a:endParaRPr>
+                    </a:p>
+                  </a:txBody>
+                  <a:tcPr marL="137160" marR="137160" marT="0" marB="0" anchor="ctr">
+                    <a:lnL w="12700" cap="flat" cmpd="sng" algn="ctr">
+                      <a:solidFill>
+                        <a:srgbClr val="E3E0D8"/>
+                      </a:solidFill>
+                      <a:prstDash val="solid"/>
+                      <a:round/>
+                      <a:headEnd type="none" w="med" len="med"/>
+                      <a:tailEnd type="none" w="med" len="med"/>
+                    </a:lnL>
+                    <a:lnR w="12700" cap="flat" cmpd="sng" algn="ctr">
+                      <a:solidFill>
+                        <a:srgbClr val="E3E0D8"/>
+                      </a:solidFill>
+                      <a:prstDash val="solid"/>
+                      <a:round/>
+                      <a:headEnd type="none" w="med" len="med"/>
+                      <a:tailEnd type="none" w="med" len="med"/>
+                    </a:lnR>
+                    <a:lnT w="12700" cap="flat" cmpd="sng" algn="ctr">
+                      <a:solidFill>
+                        <a:srgbClr val="E3E0D8"/>
+                      </a:solidFill>
+                      <a:prstDash val="solid"/>
+                      <a:round/>
+                      <a:headEnd type="none" w="med" len="med"/>
+                      <a:tailEnd type="none" w="med" len="med"/>
+                    </a:lnT>
+                    <a:lnB w="12700" cap="flat" cmpd="sng" algn="ctr">
+                      <a:solidFill>
+                        <a:srgbClr val="E3E0D8"/>
+                      </a:solidFill>
+                      <a:prstDash val="solid"/>
+                      <a:round/>
+                      <a:headEnd type="none" w="med" len="med"/>
+                      <a:tailEnd type="none" w="med" len="med"/>
+                    </a:lnB>
+                    <a:solidFill>
+                      <a:srgbClr val="FFFFFF"/>
+                    </a:solidFill>
+                  </a:tcPr>
+                </a:tc>
+                <a:tc>
+                  <a:txBody>
+                    <a:bodyPr/>
+                    <a:lstStyle/>
+                    <a:p>
+                      <a:pPr indent="0" marL="0">
+                        <a:buNone/>
+                      </a:pPr>
+                      <a:r>
+                        <a:rPr lang="en-US" sz="2000" b="1" dirty="0">
+                          <a:solidFill>
+                            <a:srgbClr val="141414"/>
+                          </a:solidFill>
+                          <a:latin typeface="Arial" pitchFamily="34" charset="0"/>
+                          <a:ea typeface="Arial" pitchFamily="34" charset="-122"/>
+                          <a:cs typeface="Arial" pitchFamily="34" charset="-120"/>
+                        </a:rPr>
+                        <a:t>~150</a:t>
+                      </a:r>
+                      <a:endParaRPr lang="en-US" sz="2000" dirty="0">
+                        <a:latin typeface="Arial" charset="0"/>
+                        <a:ea typeface="Arial" charset="0"/>
+                        <a:cs typeface="Arial" charset="0"/>
+                      </a:endParaRPr>
+                    </a:p>
+                  </a:txBody>
+                  <a:tcPr marL="137160" marR="137160" marT="0" marB="0" anchor="ctr">
+                    <a:lnL w="12700" cap="flat" cmpd="sng" algn="ctr">
+                      <a:solidFill>
+                        <a:srgbClr val="E3E0D8"/>
+                      </a:solidFill>
+                      <a:prstDash val="solid"/>
+                      <a:round/>
+                      <a:headEnd type="none" w="med" len="med"/>
+                      <a:tailEnd type="none" w="med" len="med"/>
+                    </a:lnL>
+                    <a:lnR w="12700" cap="flat" cmpd="sng" algn="ctr">
+                      <a:solidFill>
+                        <a:srgbClr val="E3E0D8"/>
+                      </a:solidFill>
+                      <a:prstDash val="solid"/>
+                      <a:round/>
+                      <a:headEnd type="none" w="med" len="med"/>
+                      <a:tailEnd type="none" w="med" len="med"/>
+                    </a:lnR>
+                    <a:lnT w="12700" cap="flat" cmpd="sng" algn="ctr">
+                      <a:solidFill>
+                        <a:srgbClr val="E3E0D8"/>
+                      </a:solidFill>
+                      <a:prstDash val="solid"/>
+                      <a:round/>
+                      <a:headEnd type="none" w="med" len="med"/>
+                      <a:tailEnd type="none" w="med" len="med"/>
+                    </a:lnT>
+                    <a:lnB w="12700" cap="flat" cmpd="sng" algn="ctr">
+                      <a:solidFill>
+                        <a:srgbClr val="E3E0D8"/>
+                      </a:solidFill>
+                      <a:prstDash val="solid"/>
+                      <a:round/>
+                      <a:headEnd type="none" w="med" len="med"/>
+                      <a:tailEnd type="none" w="med" len="med"/>
+                    </a:lnB>
+                    <a:solidFill>
+                      <a:srgbClr val="FFFFFF"/>
+                    </a:solidFill>
+                  </a:tcPr>
+                </a:tc>
+                <a:tc>
+                  <a:txBody>
+                    <a:bodyPr/>
+                    <a:lstStyle/>
+                    <a:p>
+                      <a:pPr indent="0" marL="0">
+                        <a:buNone/>
+                      </a:pPr>
+                      <a:r>
+                        <a:rPr lang="en-US" sz="2000" b="1" dirty="0">
+                          <a:solidFill>
+                            <a:srgbClr val="141414"/>
+                          </a:solidFill>
+                          <a:latin typeface="Arial" pitchFamily="34" charset="0"/>
+                          <a:ea typeface="Arial" pitchFamily="34" charset="-122"/>
+                          <a:cs typeface="Arial" pitchFamily="34" charset="-120"/>
+                        </a:rPr>
+                        <a:t>~75</a:t>
+                      </a:r>
+                      <a:endParaRPr lang="en-US" sz="2000" dirty="0">
+                        <a:latin typeface="Arial" charset="0"/>
+                        <a:ea typeface="Arial" charset="0"/>
+                        <a:cs typeface="Arial" charset="0"/>
+                      </a:endParaRPr>
+                    </a:p>
+                  </a:txBody>
+                  <a:tcPr marL="137160" marR="137160" marT="0" marB="0" anchor="ctr">
+                    <a:lnL w="12700" cap="flat" cmpd="sng" algn="ctr">
+                      <a:solidFill>
+                        <a:srgbClr val="E3E0D8"/>
+                      </a:solidFill>
+                      <a:prstDash val="solid"/>
+                      <a:round/>
+                      <a:headEnd type="none" w="med" len="med"/>
+                      <a:tailEnd type="none" w="med" len="med"/>
+                    </a:lnL>
+                    <a:lnR w="12700" cap="flat" cmpd="sng" algn="ctr">
+                      <a:solidFill>
+                        <a:srgbClr val="E3E0D8"/>
+                      </a:solidFill>
+                      <a:prstDash val="solid"/>
+                      <a:round/>
+                      <a:headEnd type="none" w="med" len="med"/>
+                      <a:tailEnd type="none" w="med" len="med"/>
+                    </a:lnR>
+                    <a:lnT w="12700" cap="flat" cmpd="sng" algn="ctr">
+                      <a:solidFill>
+                        <a:srgbClr val="E3E0D8"/>
+                      </a:solidFill>
+                      <a:prstDash val="solid"/>
+                      <a:round/>
+                      <a:headEnd type="none" w="med" len="med"/>
+                      <a:tailEnd type="none" w="med" len="med"/>
+                    </a:lnT>
+                    <a:lnB w="12700" cap="flat" cmpd="sng" algn="ctr">
+                      <a:solidFill>
+                        <a:srgbClr val="E3E0D8"/>
+                      </a:solidFill>
+                      <a:prstDash val="solid"/>
+                      <a:round/>
+                      <a:headEnd type="none" w="med" len="med"/>
+                      <a:tailEnd type="none" w="med" len="med"/>
+                    </a:lnB>
+                    <a:solidFill>
+                      <a:srgbClr val="EAF8C2"/>
+                    </a:solidFill>
+                  </a:tcPr>
+                </a:tc>
+              </a:tr>
+              <a:tr h="548640">
                 <a:tc>
                   <a:txBody>
                     <a:bodyPr/>
@@ -8372,7 +8578,7 @@
                   </a:tcPr>
                 </a:tc>
               </a:tr>
-              <a:tr h="621792">
+              <a:tr h="548640">
                 <a:tc>
                   <a:txBody>
                     <a:bodyPr/>
@@ -8578,7 +8784,7 @@
                   </a:tcPr>
                 </a:tc>
               </a:tr>
-              <a:tr h="621792">
+              <a:tr h="548640">
                 <a:tc>
                   <a:txBody>
                     <a:bodyPr/>
@@ -8821,7 +9027,7 @@
                 <a:ea typeface="Arial" pitchFamily="34" charset="-122"/>
                 <a:cs typeface="Arial" pitchFamily="34" charset="-120"/>
               </a:rPr>
-              <a:t>Orange [measure] = not measured yet. Replace before demo day.</a:t>
+              <a:t>est. = estimated from screen count (~4.5 s per screen); replace with stopwatch times. Orange = still to test.</a:t>
             </a:r>
             <a:endParaRPr lang="en-US" sz="1300" dirty="0"/>
           </a:p>

</xml_diff>

<commit_message>
Add team names to the deck; drop stopwatch from the plan
Co-Authored-By: Claude Opus 5.5 <noreply@anthropic.com>
</commit_message>
<xml_diff>
--- a/deliverables/demo-deck.pptx
+++ b/deliverables/demo-deck.pptx
@@ -1303,7 +1303,7 @@
           <a:p>
             <a:r>
               <a:rPr lang="en-US" dirty="0"/>
-              <a:t>Here is the side-by-side. GoTall shows 33 screens before its paywall and the result is still locked; we show the result on screen 7 after 4 questions, free. Screen and tap counts for GoTall come from ScreensDesign's public recording of its onboarding. The seconds marked est. are estimates from the screen count; if you have stopwatch times, say those instead. The clarity score comes from showing only the first screen of each app to five classmates. Our internal QA audit also found no dead ends in the flow.</a:t>
+              <a:t>Here is the side-by-side. GoTall shows 33 screens before its paywall and the result is still locked; we show the result on screen 7 after 4 questions, free. Screen and tap counts for GoTall come from ScreensDesign's public recording of its onboarding. The seconds marked est. are estimates from the screen count at about four and a half seconds per screen; we say so openly. The clarity score comes from showing only the first screen of each app to five classmates. Our internal QA audit also found no dead ends in the flow.</a:t>
             </a:r>
             <a:endParaRPr lang="en-US" dirty="0"/>
           </a:p>
@@ -1826,7 +1826,7 @@
                 <a:ea typeface="Arial" pitchFamily="34" charset="-122"/>
                 <a:cs typeface="Arial" pitchFamily="34" charset="-120"/>
               </a:rPr>
-              <a:t>[Team names]</a:t>
+              <a:t>Cem Aksu  ·  Pınar Işıl Şahin  ·  Batu Öncel</a:t>
             </a:r>
             <a:endParaRPr lang="en-US" sz="1800" dirty="0"/>
           </a:p>
@@ -9027,7 +9027,7 @@
                 <a:ea typeface="Arial" pitchFamily="34" charset="-122"/>
                 <a:cs typeface="Arial" pitchFamily="34" charset="-120"/>
               </a:rPr>
-              <a:t>est. = estimated from screen count (~4.5 s per screen); replace with stopwatch times. Orange = still to test.</a:t>
+              <a:t>est. = estimated from the screen count at ~4.5 s per screen. Orange = still to test.</a:t>
             </a:r>
             <a:endParaRPr lang="en-US" sz="1300" dirty="0"/>
           </a:p>

</xml_diff>

<commit_message>
Add clarity test results (GoTall 2/5, Measured 5/5)
Co-Authored-By: Claude Opus 5.5 <noreply@anthropic.com>
</commit_message>
<xml_diff>
--- a/deliverables/demo-deck.pptx
+++ b/deliverables/demo-deck.pptx
@@ -1303,7 +1303,7 @@
           <a:p>
             <a:r>
               <a:rPr lang="en-US" dirty="0"/>
-              <a:t>Here is the side-by-side. GoTall shows 33 screens before its paywall and the result is still locked; we show the result on screen 7 after 4 questions, free. Screen and tap counts for GoTall come from ScreensDesign's public recording of its onboarding. The seconds marked est. are estimates from the screen count at about four and a half seconds per screen; we say so openly. The clarity score comes from showing only the first screen of each app to five classmates. Our internal QA audit also found no dead ends in the flow.</a:t>
+              <a:t>Here is the side-by-side. GoTall shows 33 screens before its paywall and the result is still locked; we show the result on screen 7 after 4 questions, free. Screen and tap counts for GoTall come from ScreensDesign's public recording of its onboarding. The seconds marked est. are estimates from the screen count at about four and a half seconds per screen; we say so openly. For clarity we showed five classmates only the first content screen of each app for about five seconds and asked what the app does: two of five got GoTall right, all five got Measured right. Our internal QA audit also found no dead ends in the flow.</a:t>
             </a:r>
             <a:endParaRPr lang="en-US" dirty="0"/>
           </a:p>
@@ -8864,13 +8864,13 @@
                       <a:r>
                         <a:rPr lang="en-US" sz="2000" b="1" dirty="0">
                           <a:solidFill>
-                            <a:srgbClr val="FF5A1F"/>
+                            <a:srgbClr val="141414"/>
                           </a:solidFill>
                           <a:latin typeface="Arial" pitchFamily="34" charset="0"/>
                           <a:ea typeface="Arial" pitchFamily="34" charset="-122"/>
                           <a:cs typeface="Arial" pitchFamily="34" charset="-120"/>
                         </a:rPr>
-                        <a:t>[x/5]</a:t>
+                        <a:t>2/5</a:t>
                       </a:r>
                       <a:endParaRPr lang="en-US" sz="2000" dirty="0">
                         <a:latin typeface="Arial" charset="0"/>
@@ -8932,13 +8932,13 @@
                       <a:r>
                         <a:rPr lang="en-US" sz="2000" b="1" dirty="0">
                           <a:solidFill>
-                            <a:srgbClr val="FF5A1F"/>
+                            <a:srgbClr val="141414"/>
                           </a:solidFill>
                           <a:latin typeface="Arial" pitchFamily="34" charset="0"/>
                           <a:ea typeface="Arial" pitchFamily="34" charset="-122"/>
                           <a:cs typeface="Arial" pitchFamily="34" charset="-120"/>
                         </a:rPr>
-                        <a:t>[x/5]</a:t>
+                        <a:t>5/5</a:t>
                       </a:r>
                       <a:endParaRPr lang="en-US" sz="2000" dirty="0">
                         <a:latin typeface="Arial" charset="0"/>
@@ -9027,7 +9027,7 @@
                 <a:ea typeface="Arial" pitchFamily="34" charset="-122"/>
                 <a:cs typeface="Arial" pitchFamily="34" charset="-120"/>
               </a:rPr>
-              <a:t>est. = estimated from the screen count at ~4.5 s per screen. Orange = still to test.</a:t>
+              <a:t>est. = estimated from the screen count at ~4.5 s per screen. Clarity: 5 classmates saw only the first content screen of each app.</a:t>
             </a:r>
             <a:endParaRPr lang="en-US" sz="1300" dirty="0"/>
           </a:p>

</xml_diff>